<commit_message>
Corregir portada de Con todo con escena evangélica
</commit_message>
<xml_diff>
--- a/assets/presentations/2026-10-25-con-todo.pptx
+++ b/assets/presentations/2026-10-25-con-todo.pptx
@@ -2,15 +2,15 @@
 <file path=ppt/presentation.xml><?xml version="1.0" encoding="utf-8"?>
 <p:presentation xmlns:p="http://schemas.openxmlformats.org/presentationml/2006/main">
   <p:sldMasterIdLst>
-    <p:sldMasterId xmlns:r="http://schemas.openxmlformats.org/officeDocument/2006/relationships" id="2147483648" r:id="R5a8e1c16850f4ddd"/>
+    <p:sldMasterId xmlns:r="http://schemas.openxmlformats.org/officeDocument/2006/relationships" id="2147483648" r:id="R3ead2002c43f4d1b"/>
   </p:sldMasterIdLst>
   <p:notesMasterIdLst>
-    <p:notesMasterId xmlns:r="http://schemas.openxmlformats.org/officeDocument/2006/relationships" r:id="Rd6f40b87a94547bc"/>
+    <p:notesMasterId xmlns:r="http://schemas.openxmlformats.org/officeDocument/2006/relationships" r:id="R61510afb436f4546"/>
   </p:notesMasterIdLst>
   <p:sldIdLst>
-    <p:sldId xmlns:r="http://schemas.openxmlformats.org/officeDocument/2006/relationships" id="256" r:id="R0e0e7ee84103454c"/>
-    <p:sldId xmlns:r="http://schemas.openxmlformats.org/officeDocument/2006/relationships" id="257" r:id="R72618aaad0494258"/>
-    <p:sldId xmlns:r="http://schemas.openxmlformats.org/officeDocument/2006/relationships" id="258" r:id="Rebfe8703b57a4381"/>
+    <p:sldId xmlns:r="http://schemas.openxmlformats.org/officeDocument/2006/relationships" id="256" r:id="R8112f04d91054471"/>
+    <p:sldId xmlns:r="http://schemas.openxmlformats.org/officeDocument/2006/relationships" id="257" r:id="R17b61a2e277547da"/>
+    <p:sldId xmlns:r="http://schemas.openxmlformats.org/officeDocument/2006/relationships" id="258" r:id="Ra9daba9427ef49ef"/>
   </p:sldIdLst>
   <p:sldSz cx="12192000" cy="6858000"/>
   <p:notesSz cx="6858000" cy="9144000"/>
@@ -469,7 +469,7 @@
           </a:p>
           <a:p xmlns:a="http://schemas.openxmlformats.org/drawingml/2006/main">
             <a:r>
-              <a:t>La imagen es una escena contemporánea recreada con IA, no una fotografía documental.</a:t>
+              <a:t>La imagen es una recreación con IA del diálogo de Jesús con el maestro de la Ley en el contexto de Mt 22,34–40, no una fotografía documental.</a:t>
             </a:r>
           </a:p>
         </p:txBody>
@@ -792,7 +792,7 @@
   </p:cSld>
   <p:clrMap bg1="lt1" tx1="dk1" bg2="lt2" tx2="dk2" accent1="accent1" accent2="accent2" accent3="accent3" accent4="accent4" accent5="accent5" accent6="accent6" hlink="hlink" folHlink="folHlink"/>
   <p:sldLayoutIdLst>
-    <p:sldLayoutId xmlns:r="http://schemas.openxmlformats.org/officeDocument/2006/relationships" id="2147483649" r:id="R1314a19a3c204ab6"/>
+    <p:sldLayoutId xmlns:r="http://schemas.openxmlformats.org/officeDocument/2006/relationships" id="2147483649" r:id="Rc3dd2ac670d84f60"/>
   </p:sldLayoutIdLst>
   <p:txStyles>
     <p:titleStyle>
@@ -1336,7 +1336,7 @@
           <p:cNvPr id="43" name="Imagen 41">
             <a:extLst xmlns:a="http://schemas.openxmlformats.org/drawingml/2006/main">
               <a:ext uri="{FF2B5EF4-FFF2-40B4-BE49-F238E27FC236}">
-                <a16:creationId xmlns:a16="http://schemas.microsoft.com/office/drawing/2014/main" id="{D9A4189C-D0D3-4C84-A8F8-7267AF5EAF40}"/>
+                <a16:creationId xmlns:a16="http://schemas.microsoft.com/office/drawing/2014/main" id="{A3DA7C74-6263-4F0F-B707-5F8112AAD93B}"/>
               </a:ext>
             </a:extLst>
           </p:cNvPr>
@@ -1346,7 +1346,7 @@
           <p:nvPr/>
         </p:nvPicPr>
         <p:blipFill>
-          <a:blip xmlns:r="http://schemas.openxmlformats.org/officeDocument/2006/relationships" xmlns:a="http://schemas.openxmlformats.org/drawingml/2006/main" r:embed="Rc9eb6936b1384ff8"/>
+          <a:blip xmlns:r="http://schemas.openxmlformats.org/officeDocument/2006/relationships" xmlns:a="http://schemas.openxmlformats.org/drawingml/2006/main" r:embed="R9cd4ac51439a4c96"/>
           <a:srcRect xmlns:a="http://schemas.openxmlformats.org/drawingml/2006/main" l="0" t="27" r="0" b="27"/>
           <a:stretch xmlns:a="http://schemas.openxmlformats.org/drawingml/2006/main">
             <a:fillRect l="0" t="0" r="0" b="0"/>

</xml_diff>